<commit_message>
W03 D1: the introduction deck names stages instead of this week's days, so no graded event carries a day
Co-Authored-By: Claude Opus 5.5 <noreply@anthropic.com>
Claude-Session: https://claude.ai/code/session_0124KbFAUFwPsNP9jL1MCV9G
</commit_message>
<xml_diff>
--- a/content/W03/D1/slides/C2_W03_D01_introduction_STUDENT.pptx
+++ b/content/W03/D1/slides/C2_W03_D01_introduction_STUDENT.pptx
@@ -607,12 +607,12 @@
           <a:lstStyle/>
           <a:p>
             <a:r>
-              <a:t>LIVE, the Programme Head, 4 minutes. Walk the days left to right. Three things to land:</a:t>
-            </a:r>
-          </a:p>
-          <a:p>
-            <a:r>
-              <a:t>the headline claim is stated on Wednesday so that Thursday tests it rather than finishes it; the</a:t>
+              <a:t>LIVE, the Programme Head, 4 minutes. Walk the stages left to right. Three things to land:</a:t>
+            </a:r>
+          </a:p>
+          <a:p>
+            <a:r>
+              <a:t>the headline claim is stated in stage 2 so that stage 3 tests it rather than finishes it; the</a:t>
             </a:r>
           </a:p>
           <a:p>
@@ -627,7 +627,7 @@
           </a:p>
           <a:p>
             <a:r>
-              <a:t>Tuesday 20 October is a gazetted holiday. The time after the second block each day is open build</a:t>
+              <a:t>One day this week is a gazetted holiday. The time after the second block each day is open build</a:t>
             </a:r>
           </a:p>
           <a:p>
@@ -1312,7 +1312,7 @@
           </a:p>
           <a:p>
             <a:r>
-              <a:t>collected report rested on. The Your-turn question is Wednesday's interview question, asked early on</a:t>
+              <a:t>collected report rested on. The Your-turn question is a later build day's interview question, asked early on</a:t>
             </a:r>
           </a:p>
           <a:p>
@@ -1552,12 +1552,12 @@
           <a:lstStyle/>
           <a:p>
             <a:r>
-              <a:t>LIVE, the Programme Head, 2 minutes. Thursday's viva reads this log. Prepared answers break where</a:t>
-            </a:r>
-          </a:p>
-          <a:p>
-            <a:r>
-              <a:t>the log is thin, so an entry written on Monday is worth more than three written on Thursday night.</a:t>
+              <a:t>LIVE, the Programme Head, 2 minutes. The mock's viva reads this log. Prepared answers break where</a:t>
+            </a:r>
+          </a:p>
+          <a:p>
+            <a:r>
+              <a:t>the log is thin, so an entry written today is worth more than three written the night before the viva.</a:t>
             </a:r>
           </a:p>
           <a:p>
@@ -1637,7 +1637,7 @@
           </a:p>
           <a:p>
             <a:r>
-              <a:t>cannot answer them on Wednesday is stuck and should say so, because Thursday opens the mocks.</a:t>
+              <a:t>cannot answer them at the checkpoint is stuck and should say so then, because the mocks follow.</a:t>
             </a:r>
           </a:p>
           <a:p>
@@ -1832,12 +1832,12 @@
           </a:p>
           <a:p>
             <a:r>
-              <a:t>it in your challenges log as a hypothesis, and test it on Wednesday. A hypothesis said aloud on</a:t>
-            </a:r>
-          </a:p>
-          <a:p>
-            <a:r>
-              <a:t>Monday is a guess the whole room hears.</a:t>
+              <a:t>it in your challenges log as a hypothesis, and test it once the build starts. A hypothesis said</a:t>
+            </a:r>
+          </a:p>
+          <a:p>
+            <a:r>
+              <a:t>aloud today is a guess the whole room hears.</a:t>
             </a:r>
           </a:p>
         </p:txBody>
@@ -6071,7 +6071,7 @@
                 </a:solidFill>
                 <a:latin typeface="Georgia"/>
               </a:rPr>
-              <a:t>The week, day by day</a:t>
+              <a:t>The week, in five stages</a:t>
             </a:r>
           </a:p>
         </p:txBody>
@@ -6106,7 +6106,7 @@
                 </a:solidFill>
                 <a:latin typeface="Calibri"/>
               </a:rPr>
-              <a:t>Tuesday is Dussehra, so Wednesday carries two build days.</a:t>
+              <a:t>A holiday falls inside the week, so one day carries two build days.</a:t>
             </a:r>
           </a:p>
         </p:txBody>
@@ -6185,7 +6185,7 @@
                 </a:solidFill>
                 <a:latin typeface="Calibri"/>
               </a:rPr>
-              <a:t>MONDAY</a:t>
+              <a:t>STAGE 1</a:t>
             </a:r>
           </a:p>
         </p:txBody>
@@ -6388,7 +6388,7 @@
                 </a:solidFill>
                 <a:latin typeface="Calibri"/>
               </a:rPr>
-              <a:t>WEDNESDAY</a:t>
+              <a:t>STAGE 2</a:t>
             </a:r>
           </a:p>
         </p:txBody>
@@ -6591,7 +6591,7 @@
                 </a:solidFill>
                 <a:latin typeface="Calibri"/>
               </a:rPr>
-              <a:t>THURSDAY</a:t>
+              <a:t>STAGE 3</a:t>
             </a:r>
           </a:p>
         </p:txBody>
@@ -6794,7 +6794,7 @@
                 </a:solidFill>
                 <a:latin typeface="Calibri"/>
               </a:rPr>
-              <a:t>FRIDAY</a:t>
+              <a:t>STAGE 4</a:t>
             </a:r>
           </a:p>
         </p:txBody>
@@ -6997,7 +6997,7 @@
                 </a:solidFill>
                 <a:latin typeface="Calibri"/>
               </a:rPr>
-              <a:t>SATURDAY</a:t>
+              <a:t>STAGE 5</a:t>
             </a:r>
           </a:p>
         </p:txBody>
@@ -17574,7 +17574,7 @@
                 </a:solidFill>
                 <a:latin typeface="Georgia"/>
               </a:rPr>
-              <a:t>The close, and Wednesday's checkpoint</a:t>
+              <a:t>The close, and the next checkpoint</a:t>
             </a:r>
           </a:p>
         </p:txBody>
@@ -17609,7 +17609,7 @@
                 </a:solidFill>
                 <a:latin typeface="Calibri"/>
               </a:rPr>
-              <a:t>Scopes pinned today; three checkpoint questions per group on Wednesday.</a:t>
+              <a:t>Scopes pinned today; three checkpoint questions per group next build day.</a:t>
             </a:r>
           </a:p>
         </p:txBody>
@@ -17624,7 +17624,7 @@
         </p:nvGraphicFramePr>
         <p:xfrm>
           <a:off x="530352" y="1956816"/>
-          <a:ext cx="11130990" cy="1849120"/>
+          <a:ext cx="11130990" cy="2332736"/>
         </p:xfrm>
         <a:graphic>
           <a:graphicData uri="http://schemas.openxmlformats.org/drawingml/2006/table">
@@ -17633,8 +17633,8 @@
                 <a:tableStyleId>{2D5ABB26-0587-4C30-8999-92F81FD0307C}</a:tableStyleId>
               </a:tblPr>
               <a:tblGrid>
-                <a:gridCol w="3380744"/>
-                <a:gridCol w="7750246"/>
+                <a:gridCol w="4389567"/>
+                <a:gridCol w="6741423"/>
               </a:tblGrid>
               <a:tr h="369824">
                 <a:tc>
@@ -17728,7 +17728,7 @@
                   </a:tcPr>
                 </a:tc>
               </a:tr>
-              <a:tr h="369824">
+              <a:tr h="611632">
                 <a:tc>
                   <a:txBody>
                     <a:bodyPr/>
@@ -17741,7 +17741,7 @@
                           </a:solidFill>
                           <a:latin typeface="Calibri"/>
                         </a:rPr>
-                        <a:t>Tonight, open build time</a:t>
+                        <a:t>After today's blocks, open build time</a:t>
                       </a:r>
                     </a:p>
                   </a:txBody>
@@ -17787,7 +17787,7 @@
                           </a:solidFill>
                           <a:latin typeface="Calibri"/>
                         </a:rPr>
-                        <a:t>Wednesday, 30 min</a:t>
+                        <a:t>Next build day, 30 min</a:t>
                       </a:r>
                     </a:p>
                   </a:txBody>
@@ -17820,7 +17820,7 @@
                   </a:tcPr>
                 </a:tc>
               </a:tr>
-              <a:tr h="369824">
+              <a:tr h="611632">
                 <a:tc>
                   <a:txBody>
                     <a:bodyPr/>
@@ -17833,7 +17833,7 @@
                           </a:solidFill>
                           <a:latin typeface="Calibri"/>
                         </a:rPr>
-                        <a:t>Wednesday, 20 min</a:t>
+                        <a:t>Next build day, 20 min</a:t>
                       </a:r>
                     </a:p>
                   </a:txBody>
@@ -17878,7 +17878,7 @@
         </p:nvSpPr>
         <p:spPr>
           <a:xfrm>
-            <a:off x="530352" y="4061968"/>
+            <a:off x="530352" y="4545584"/>
             <a:ext cx="11130991" cy="862584"/>
           </a:xfrm>
           <a:prstGeom prst="roundRect">
@@ -17932,7 +17932,7 @@
         </p:nvSpPr>
         <p:spPr>
           <a:xfrm>
-            <a:off x="758952" y="4264660"/>
+            <a:off x="758952" y="4748276"/>
             <a:ext cx="457200" cy="457200"/>
           </a:xfrm>
           <a:prstGeom prst="ellipse">
@@ -17984,7 +17984,7 @@
         </p:blipFill>
         <p:spPr>
           <a:xfrm>
-            <a:off x="868680" y="4374388"/>
+            <a:off x="868680" y="4858004"/>
             <a:ext cx="237744" cy="237744"/>
           </a:xfrm>
           <a:prstGeom prst="rect">
@@ -18000,7 +18000,7 @@
         </p:nvSpPr>
         <p:spPr>
           <a:xfrm>
-            <a:off x="1399031" y="4208272"/>
+            <a:off x="1399031" y="4691888"/>
             <a:ext cx="9987991" cy="160401"/>
           </a:xfrm>
           <a:prstGeom prst="rect">
@@ -18035,7 +18035,7 @@
         </p:nvSpPr>
         <p:spPr>
           <a:xfrm>
-            <a:off x="1399031" y="4427728"/>
+            <a:off x="1399031" y="4911344"/>
             <a:ext cx="9987991" cy="423672"/>
           </a:xfrm>
           <a:prstGeom prst="rect">
@@ -20562,7 +20562,7 @@
                 </a:solidFill>
                 <a:latin typeface="Calibri"/>
               </a:rPr>
-              <a:t>"I do not need a dashboard. I need to know where the 13 points went, and what to do on Monday."</a:t>
+              <a:t>"I do not need a dashboard. I need to know where the 13 points went, and what to do next."</a:t>
             </a:r>
           </a:p>
         </p:txBody>

</xml_diff>